<commit_message>
Actualización de cambios recientes
</commit_message>
<xml_diff>
--- a/DIAGRAMA E-R y Relacional.pptx
+++ b/DIAGRAMA E-R y Relacional.pptx
@@ -124,6 +124,50 @@
 </p:presentation>
 </file>
 
+<file path=ppt/changesInfos/changesInfo1.xml><?xml version="1.0" encoding="utf-8"?>
+<pc:chgInfo xmlns:a="http://schemas.openxmlformats.org/drawingml/2006/main" xmlns:r="http://schemas.openxmlformats.org/officeDocument/2006/relationships" xmlns:ac="http://schemas.microsoft.com/office/drawing/2013/main/command" xmlns:pc="http://schemas.microsoft.com/office/powerpoint/2013/main/command">
+  <pc:docChgLst>
+    <pc:chgData name="Jesus Rueda" userId="7dee701d09d07bb3" providerId="LiveId" clId="{24E58A64-B7C4-4358-9E62-AC6A75F12EFA}"/>
+    <pc:docChg chg="modSld">
+      <pc:chgData name="Jesus Rueda" userId="7dee701d09d07bb3" providerId="LiveId" clId="{24E58A64-B7C4-4358-9E62-AC6A75F12EFA}" dt="2026-06-01T04:18:46.359" v="20" actId="1076"/>
+      <pc:docMkLst>
+        <pc:docMk/>
+      </pc:docMkLst>
+      <pc:sldChg chg="modSp mod">
+        <pc:chgData name="Jesus Rueda" userId="7dee701d09d07bb3" providerId="LiveId" clId="{24E58A64-B7C4-4358-9E62-AC6A75F12EFA}" dt="2026-06-01T04:18:46.359" v="20" actId="1076"/>
+        <pc:sldMkLst>
+          <pc:docMk/>
+          <pc:sldMk cId="0" sldId="256"/>
+        </pc:sldMkLst>
+        <pc:picChg chg="mod">
+          <ac:chgData name="Jesus Rueda" userId="7dee701d09d07bb3" providerId="LiveId" clId="{24E58A64-B7C4-4358-9E62-AC6A75F12EFA}" dt="2026-06-01T04:18:46.359" v="20" actId="1076"/>
+          <ac:picMkLst>
+            <pc:docMk/>
+            <pc:sldMk cId="0" sldId="256"/>
+            <ac:picMk id="2" creationId="{00000000-0000-0000-0000-000000000000}"/>
+          </ac:picMkLst>
+        </pc:picChg>
+      </pc:sldChg>
+      <pc:sldChg chg="modSp mod">
+        <pc:chgData name="Jesus Rueda" userId="7dee701d09d07bb3" providerId="LiveId" clId="{24E58A64-B7C4-4358-9E62-AC6A75F12EFA}" dt="2026-06-01T03:38:36.399" v="18" actId="1076"/>
+        <pc:sldMkLst>
+          <pc:docMk/>
+          <pc:sldMk cId="0" sldId="257"/>
+        </pc:sldMkLst>
+        <pc:picChg chg="mod">
+          <ac:chgData name="Jesus Rueda" userId="7dee701d09d07bb3" providerId="LiveId" clId="{24E58A64-B7C4-4358-9E62-AC6A75F12EFA}" dt="2026-06-01T03:38:36.399" v="18" actId="1076"/>
+          <ac:picMkLst>
+            <pc:docMk/>
+            <pc:sldMk cId="0" sldId="257"/>
+            <ac:picMk id="2" creationId="{00000000-0000-0000-0000-000000000000}"/>
+          </ac:picMkLst>
+        </pc:picChg>
+      </pc:sldChg>
+    </pc:docChg>
+  </pc:docChgLst>
+</pc:chgInfo>
+</file>
+
 <file path=ppt/slideLayouts/slideLayout1.xml><?xml version="1.0" encoding="utf-8"?>
 <p:sldLayout xmlns:a="http://schemas.openxmlformats.org/drawingml/2006/main" xmlns:r="http://schemas.openxmlformats.org/officeDocument/2006/relationships" xmlns:p="http://schemas.openxmlformats.org/presentationml/2006/main" type="title" preserve="1">
   <p:cSld name="Title Slide">
@@ -304,7 +348,7 @@
             <a:fld id="{1D8BD707-D9CF-40AE-B4C6-C98DA3205C09}" type="datetimeFigureOut">
               <a:rPr lang="en-US" smtClean="0"/>
               <a:pPr/>
-              <a:t>5/30/2026</a:t>
+              <a:t>5/31/2026</a:t>
             </a:fld>
             <a:endParaRPr lang="en-US"/>
           </a:p>
@@ -469,7 +513,7 @@
             <a:fld id="{1D8BD707-D9CF-40AE-B4C6-C98DA3205C09}" type="datetimeFigureOut">
               <a:rPr lang="en-US" smtClean="0"/>
               <a:pPr/>
-              <a:t>5/30/2026</a:t>
+              <a:t>5/31/2026</a:t>
             </a:fld>
             <a:endParaRPr lang="en-US"/>
           </a:p>
@@ -644,7 +688,7 @@
             <a:fld id="{1D8BD707-D9CF-40AE-B4C6-C98DA3205C09}" type="datetimeFigureOut">
               <a:rPr lang="en-US" smtClean="0"/>
               <a:pPr/>
-              <a:t>5/30/2026</a:t>
+              <a:t>5/31/2026</a:t>
             </a:fld>
             <a:endParaRPr lang="en-US"/>
           </a:p>
@@ -809,7 +853,7 @@
             <a:fld id="{1D8BD707-D9CF-40AE-B4C6-C98DA3205C09}" type="datetimeFigureOut">
               <a:rPr lang="en-US" smtClean="0"/>
               <a:pPr/>
-              <a:t>5/30/2026</a:t>
+              <a:t>5/31/2026</a:t>
             </a:fld>
             <a:endParaRPr lang="en-US"/>
           </a:p>
@@ -1051,7 +1095,7 @@
             <a:fld id="{1D8BD707-D9CF-40AE-B4C6-C98DA3205C09}" type="datetimeFigureOut">
               <a:rPr lang="en-US" smtClean="0"/>
               <a:pPr/>
-              <a:t>5/30/2026</a:t>
+              <a:t>5/31/2026</a:t>
             </a:fld>
             <a:endParaRPr lang="en-US"/>
           </a:p>
@@ -1333,7 +1377,7 @@
             <a:fld id="{1D8BD707-D9CF-40AE-B4C6-C98DA3205C09}" type="datetimeFigureOut">
               <a:rPr lang="en-US" smtClean="0"/>
               <a:pPr/>
-              <a:t>5/30/2026</a:t>
+              <a:t>5/31/2026</a:t>
             </a:fld>
             <a:endParaRPr lang="en-US"/>
           </a:p>
@@ -1749,7 +1793,7 @@
             <a:fld id="{1D8BD707-D9CF-40AE-B4C6-C98DA3205C09}" type="datetimeFigureOut">
               <a:rPr lang="en-US" smtClean="0"/>
               <a:pPr/>
-              <a:t>5/30/2026</a:t>
+              <a:t>5/31/2026</a:t>
             </a:fld>
             <a:endParaRPr lang="en-US"/>
           </a:p>
@@ -1863,7 +1907,7 @@
             <a:fld id="{1D8BD707-D9CF-40AE-B4C6-C98DA3205C09}" type="datetimeFigureOut">
               <a:rPr lang="en-US" smtClean="0"/>
               <a:pPr/>
-              <a:t>5/30/2026</a:t>
+              <a:t>5/31/2026</a:t>
             </a:fld>
             <a:endParaRPr lang="en-US"/>
           </a:p>
@@ -1955,7 +1999,7 @@
             <a:fld id="{1D8BD707-D9CF-40AE-B4C6-C98DA3205C09}" type="datetimeFigureOut">
               <a:rPr lang="en-US" smtClean="0"/>
               <a:pPr/>
-              <a:t>5/30/2026</a:t>
+              <a:t>5/31/2026</a:t>
             </a:fld>
             <a:endParaRPr lang="en-US"/>
           </a:p>
@@ -2227,7 +2271,7 @@
             <a:fld id="{1D8BD707-D9CF-40AE-B4C6-C98DA3205C09}" type="datetimeFigureOut">
               <a:rPr lang="en-US" smtClean="0"/>
               <a:pPr/>
-              <a:t>5/30/2026</a:t>
+              <a:t>5/31/2026</a:t>
             </a:fld>
             <a:endParaRPr lang="en-US"/>
           </a:p>
@@ -2476,7 +2520,7 @@
             <a:fld id="{1D8BD707-D9CF-40AE-B4C6-C98DA3205C09}" type="datetimeFigureOut">
               <a:rPr lang="en-US" smtClean="0"/>
               <a:pPr/>
-              <a:t>5/30/2026</a:t>
+              <a:t>5/31/2026</a:t>
             </a:fld>
             <a:endParaRPr lang="en-US"/>
           </a:p>
@@ -2684,7 +2728,7 @@
             <a:fld id="{1D8BD707-D9CF-40AE-B4C6-C98DA3205C09}" type="datetimeFigureOut">
               <a:rPr lang="en-US" smtClean="0"/>
               <a:pPr/>
-              <a:t>5/30/2026</a:t>
+              <a:t>5/31/2026</a:t>
             </a:fld>
             <a:endParaRPr lang="en-US"/>
           </a:p>
@@ -3081,7 +3125,7 @@
         </p:blipFill>
         <p:spPr>
           <a:xfrm>
-            <a:off x="0" y="0"/>
+            <a:off x="228600" y="-228600"/>
             <a:ext cx="24384000" cy="13716000"/>
           </a:xfrm>
           <a:prstGeom prst="rect">
@@ -3140,7 +3184,7 @@
         </p:blipFill>
         <p:spPr>
           <a:xfrm>
-            <a:off x="0" y="0"/>
+            <a:off x="-38100" y="38100"/>
             <a:ext cx="24384000" cy="13716000"/>
           </a:xfrm>
           <a:prstGeom prst="rect">

</xml_diff>